<commit_message>
Update diagrams, exercse and slides
</commit_message>
<xml_diff>
--- a/05 Thread Synchronization 1/Thread Synchronization.pptx
+++ b/05 Thread Synchronization 1/Thread Synchronization.pptx
@@ -48,9 +48,9 @@
     <p:sldId id="368" r:id="rId39"/>
     <p:sldId id="369" r:id="rId40"/>
     <p:sldId id="382" r:id="rId41"/>
-    <p:sldId id="353" r:id="rId42"/>
-    <p:sldId id="338" r:id="rId43"/>
-    <p:sldId id="309" r:id="rId44"/>
+    <p:sldId id="309" r:id="rId42"/>
+    <p:sldId id="353" r:id="rId43"/>
+    <p:sldId id="338" r:id="rId44"/>
     <p:sldId id="337" r:id="rId45"/>
     <p:sldId id="339" r:id="rId46"/>
     <p:sldId id="340" r:id="rId47"/>
@@ -260,7 +260,7 @@
           <a:p>
             <a:fld id="{C3D45B35-5990-4A22-9246-3EAB55A12994}" type="datetimeFigureOut">
               <a:rPr lang="da-DK" smtClean="0"/>
-              <a:t>24.09.2025</a:t>
+              <a:t>23.09.2026</a:t>
             </a:fld>
             <a:endParaRPr lang="da-DK"/>
           </a:p>
@@ -1275,37 +1275,23 @@
             </a:r>
             <a:r>
               <a:rPr lang="en-US" dirty="0"/>
-              <a:t> toy is an orange rubber ball</a:t>
-            </a:r>
-            <a:r>
-              <a:rPr lang="en-US"/>
-              <a:t>. </a:t>
-            </a:r>
-          </a:p>
-          <a:p>
-            <a:r>
-              <a:rPr lang="en-US" b="1"/>
+              <a:t> toy is an orange rubber ball. </a:t>
+            </a:r>
+          </a:p>
+          <a:p>
+            <a:r>
+              <a:rPr lang="en-US" b="1" dirty="0"/>
               <a:t>Po</a:t>
             </a:r>
             <a:r>
-              <a:rPr lang="en-US"/>
-              <a:t> </a:t>
-            </a:r>
-            <a:r>
               <a:rPr lang="en-US" dirty="0"/>
-              <a:t>(played by </a:t>
-            </a:r>
-            <a:r>
-              <a:rPr lang="en-US" dirty="0" err="1">
-                <a:hlinkClick r:id="rId17" tooltip="Pui Fan Lee"/>
-              </a:rPr>
-              <a:t>Pui</a:t>
+              <a:t> (played by </a:t>
             </a:r>
             <a:r>
               <a:rPr lang="en-US" dirty="0">
                 <a:hlinkClick r:id="rId17" tooltip="Pui Fan Lee"/>
               </a:rPr>
-              <a:t> Fan Lee</a:t>
+              <a:t>Pui Fan Lee</a:t>
             </a:r>
             <a:r>
               <a:rPr lang="en-US" dirty="0"/>
@@ -1315,13 +1301,7 @@
               <a:rPr lang="en-US" dirty="0">
                 <a:hlinkClick r:id="rId18" tooltip="Rachelle Beinart"/>
               </a:rPr>
-              <a:t>Rachelle </a:t>
-            </a:r>
-            <a:r>
-              <a:rPr lang="en-US" dirty="0" err="1">
-                <a:hlinkClick r:id="rId18" tooltip="Rachelle Beinart"/>
-              </a:rPr>
-              <a:t>Beinart</a:t>
+              <a:t>Rachelle Beinart</a:t>
             </a:r>
             <a:r>
               <a:rPr lang="en-US" dirty="0"/>
@@ -1335,15 +1315,7 @@
             </a:r>
             <a:r>
               <a:rPr lang="en-US" dirty="0"/>
-              <a:t> is the fourth </a:t>
-            </a:r>
-            <a:r>
-              <a:rPr lang="en-US" dirty="0" err="1"/>
-              <a:t>Teletubby</a:t>
-            </a:r>
-            <a:r>
-              <a:rPr lang="en-US" dirty="0"/>
-              <a:t>, as well as the shortest and youngest. She is red and has an antenna shaped like a stick used for blowing </a:t>
+              <a:t> is the fourth Teletubby, as well as the shortest and youngest. She is red and has an antenna shaped like a stick used for blowing </a:t>
             </a:r>
             <a:r>
               <a:rPr lang="en-US" dirty="0">
@@ -6401,25 +6373,7 @@
           <a:bodyPr/>
           <a:lstStyle/>
           <a:p>
-            <a:r>
-              <a:rPr lang="en-DK" dirty="0"/>
-              <a:t>This can be solved with use of async / await</a:t>
-            </a:r>
-          </a:p>
-          <a:p>
-            <a:endParaRPr lang="en-DK" dirty="0"/>
-          </a:p>
-          <a:p>
-            <a:r>
-              <a:rPr lang="en-DK" dirty="0"/>
-              <a:t>Progress must be updated manually </a:t>
-            </a:r>
-          </a:p>
-          <a:p>
-            <a:r>
-              <a:rPr lang="en-DK" dirty="0"/>
-              <a:t>Cancellation is done with Cancellation token.</a:t>
-            </a:r>
+            <a:endParaRPr lang="da-DK" dirty="0"/>
           </a:p>
         </p:txBody>
       </p:sp>
@@ -6430,7 +6384,7 @@
             <a:spLocks noGrp="1"/>
           </p:cNvSpPr>
           <p:nvPr>
-            <p:ph type="sldNum" sz="quarter" idx="5"/>
+            <p:ph type="sldNum" sz="quarter" idx="10"/>
           </p:nvPr>
         </p:nvSpPr>
         <p:spPr/>
@@ -6440,7 +6394,7 @@
           <a:p>
             <a:fld id="{E41AB761-37ED-4EFA-99FC-D346B55B115C}" type="slidenum">
               <a:rPr lang="da-DK" smtClean="0"/>
-              <a:t>42</a:t>
+              <a:t>41</a:t>
             </a:fld>
             <a:endParaRPr lang="da-DK"/>
           </a:p>
@@ -6449,7 +6403,7 @@
     </p:spTree>
     <p:extLst>
       <p:ext uri="{BB962C8B-B14F-4D97-AF65-F5344CB8AC3E}">
-        <p14:creationId xmlns:p14="http://schemas.microsoft.com/office/powerpoint/2010/main" val="3095431759"/>
+        <p14:creationId xmlns:p14="http://schemas.microsoft.com/office/powerpoint/2010/main" val="2774144919"/>
       </p:ext>
     </p:extLst>
   </p:cSld>
@@ -6503,7 +6457,25 @@
           <a:bodyPr/>
           <a:lstStyle/>
           <a:p>
-            <a:endParaRPr lang="da-DK" dirty="0"/>
+            <a:r>
+              <a:rPr lang="en-DK" dirty="0"/>
+              <a:t>This can be solved with use of async / await</a:t>
+            </a:r>
+          </a:p>
+          <a:p>
+            <a:endParaRPr lang="en-DK" dirty="0"/>
+          </a:p>
+          <a:p>
+            <a:r>
+              <a:rPr lang="en-DK" dirty="0"/>
+              <a:t>Progress must be updated manually </a:t>
+            </a:r>
+          </a:p>
+          <a:p>
+            <a:r>
+              <a:rPr lang="en-DK" dirty="0"/>
+              <a:t>Cancellation is done with Cancellation token.</a:t>
+            </a:r>
           </a:p>
         </p:txBody>
       </p:sp>
@@ -6514,7 +6486,7 @@
             <a:spLocks noGrp="1"/>
           </p:cNvSpPr>
           <p:nvPr>
-            <p:ph type="sldNum" sz="quarter" idx="10"/>
+            <p:ph type="sldNum" sz="quarter" idx="5"/>
           </p:nvPr>
         </p:nvSpPr>
         <p:spPr/>
@@ -6533,7 +6505,7 @@
     </p:spTree>
     <p:extLst>
       <p:ext uri="{BB962C8B-B14F-4D97-AF65-F5344CB8AC3E}">
-        <p14:creationId xmlns:p14="http://schemas.microsoft.com/office/powerpoint/2010/main" val="2774144919"/>
+        <p14:creationId xmlns:p14="http://schemas.microsoft.com/office/powerpoint/2010/main" val="3095431759"/>
       </p:ext>
     </p:extLst>
   </p:cSld>
@@ -17709,7 +17681,23 @@
                   <a:prstClr val="black"/>
                 </a:solidFill>
               </a:rPr>
-              <a:t>, but then others can lock on the same object as well and prevent concurrency. So don’t do that!</a:t>
+              <a:t>, but then others can lock on the same object as well and prevent concurrency. </a:t>
+            </a:r>
+            <a:r>
+              <a:rPr lang="en-US" b="1" dirty="0">
+                <a:solidFill>
+                  <a:prstClr val="black"/>
+                </a:solidFill>
+              </a:rPr>
+              <a:t>So don’t do that</a:t>
+            </a:r>
+            <a:r>
+              <a:rPr lang="en-US" dirty="0">
+                <a:solidFill>
+                  <a:prstClr val="black"/>
+                </a:solidFill>
+              </a:rPr>
+              <a:t>!</a:t>
             </a:r>
             <a:endParaRPr lang="da-DK" dirty="0"/>
           </a:p>
@@ -31214,16 +31202,12 @@
           <a:lstStyle/>
           <a:p>
             <a:r>
+              <a:rPr lang="da-DK" dirty="0"/>
+              <a:t>Dispatch or </a:t>
+            </a:r>
+            <a:r>
               <a:rPr lang="da-DK" dirty="0" err="1"/>
-              <a:t>Invoke</a:t>
-            </a:r>
-            <a:r>
-              <a:rPr lang="da-DK" dirty="0"/>
-              <a:t> or </a:t>
-            </a:r>
-            <a:r>
-              <a:rPr lang="da-DK" dirty="0" err="1"/>
-              <a:t>BeginInvoke</a:t>
+              <a:t>DispatchAsync</a:t>
             </a:r>
             <a:r>
               <a:rPr lang="da-DK" dirty="0"/>
@@ -31810,431 +31794,6 @@
 </file>
 
 <file path=ppt/slides/slide41.xml><?xml version="1.0" encoding="utf-8"?>
-<p:sld xmlns:a="http://schemas.openxmlformats.org/drawingml/2006/main" xmlns:r="http://schemas.openxmlformats.org/officeDocument/2006/relationships" xmlns:p="http://schemas.openxmlformats.org/presentationml/2006/main">
-  <p:cSld>
-    <p:spTree>
-      <p:nvGrpSpPr>
-        <p:cNvPr id="1" name=""/>
-        <p:cNvGrpSpPr/>
-        <p:nvPr/>
-      </p:nvGrpSpPr>
-      <p:grpSpPr>
-        <a:xfrm>
-          <a:off x="0" y="0"/>
-          <a:ext cx="0" cy="0"/>
-          <a:chOff x="0" y="0"/>
-          <a:chExt cx="0" cy="0"/>
-        </a:xfrm>
-      </p:grpSpPr>
-      <p:sp>
-        <p:nvSpPr>
-          <p:cNvPr id="2" name="Title 1"/>
-          <p:cNvSpPr>
-            <a:spLocks noGrp="1"/>
-          </p:cNvSpPr>
-          <p:nvPr>
-            <p:ph type="title"/>
-          </p:nvPr>
-        </p:nvSpPr>
-        <p:spPr/>
-        <p:txBody>
-          <a:bodyPr/>
-          <a:lstStyle/>
-          <a:p>
-            <a:r>
-              <a:rPr lang="da-DK" dirty="0"/>
-              <a:t>Extra </a:t>
-            </a:r>
-            <a:r>
-              <a:rPr lang="da-DK" dirty="0" err="1"/>
-              <a:t>stuff</a:t>
-            </a:r>
-            <a:endParaRPr lang="da-DK" dirty="0"/>
-          </a:p>
-        </p:txBody>
-      </p:sp>
-      <p:pic>
-        <p:nvPicPr>
-          <p:cNvPr id="4" name="Content Placeholder 3"/>
-          <p:cNvPicPr>
-            <a:picLocks noGrp="1" noChangeAspect="1"/>
-          </p:cNvPicPr>
-          <p:nvPr>
-            <p:ph idx="1"/>
-          </p:nvPr>
-        </p:nvPicPr>
-        <p:blipFill>
-          <a:blip r:embed="rId2">
-            <a:extLst>
-              <a:ext uri="{28A0092B-C50C-407E-A947-70E740481C1C}">
-                <a14:useLocalDpi xmlns:a14="http://schemas.microsoft.com/office/drawing/2010/main" val="0"/>
-              </a:ext>
-            </a:extLst>
-          </a:blip>
-          <a:stretch>
-            <a:fillRect/>
-          </a:stretch>
-        </p:blipFill>
-        <p:spPr>
-          <a:xfrm>
-            <a:off x="1033764" y="2022959"/>
-            <a:ext cx="10124472" cy="3442320"/>
-          </a:xfrm>
-        </p:spPr>
-      </p:pic>
-    </p:spTree>
-    <p:extLst>
-      <p:ext uri="{BB962C8B-B14F-4D97-AF65-F5344CB8AC3E}">
-        <p14:creationId xmlns:p14="http://schemas.microsoft.com/office/powerpoint/2010/main" val="293524918"/>
-      </p:ext>
-    </p:extLst>
-  </p:cSld>
-  <p:clrMapOvr>
-    <a:masterClrMapping/>
-  </p:clrMapOvr>
-</p:sld>
-</file>
-
-<file path=ppt/slides/slide42.xml><?xml version="1.0" encoding="utf-8"?>
-<p:sld xmlns:a="http://schemas.openxmlformats.org/drawingml/2006/main" xmlns:r="http://schemas.openxmlformats.org/officeDocument/2006/relationships" xmlns:p="http://schemas.openxmlformats.org/presentationml/2006/main">
-  <p:cSld>
-    <p:spTree>
-      <p:nvGrpSpPr>
-        <p:cNvPr id="1" name=""/>
-        <p:cNvGrpSpPr/>
-        <p:nvPr/>
-      </p:nvGrpSpPr>
-      <p:grpSpPr>
-        <a:xfrm>
-          <a:off x="0" y="0"/>
-          <a:ext cx="0" cy="0"/>
-          <a:chOff x="0" y="0"/>
-          <a:chExt cx="0" cy="0"/>
-        </a:xfrm>
-      </p:grpSpPr>
-      <p:sp>
-        <p:nvSpPr>
-          <p:cNvPr id="2" name="Title 1"/>
-          <p:cNvSpPr>
-            <a:spLocks noGrp="1"/>
-          </p:cNvSpPr>
-          <p:nvPr>
-            <p:ph type="title"/>
-          </p:nvPr>
-        </p:nvSpPr>
-        <p:spPr/>
-        <p:txBody>
-          <a:bodyPr/>
-          <a:lstStyle/>
-          <a:p>
-            <a:r>
-              <a:rPr lang="da-DK" dirty="0"/>
-              <a:t>Not </a:t>
-            </a:r>
-            <a:r>
-              <a:rPr lang="da-DK" dirty="0" err="1"/>
-              <a:t>solved</a:t>
-            </a:r>
-            <a:r>
-              <a:rPr lang="da-DK" dirty="0"/>
-              <a:t> </a:t>
-            </a:r>
-            <a:r>
-              <a:rPr lang="da-DK" dirty="0" err="1"/>
-              <a:t>here</a:t>
-            </a:r>
-            <a:endParaRPr lang="da-DK" dirty="0"/>
-          </a:p>
-        </p:txBody>
-      </p:sp>
-      <p:sp>
-        <p:nvSpPr>
-          <p:cNvPr id="3" name="Content Placeholder 2"/>
-          <p:cNvSpPr>
-            <a:spLocks noGrp="1"/>
-          </p:cNvSpPr>
-          <p:nvPr>
-            <p:ph idx="1"/>
-          </p:nvPr>
-        </p:nvSpPr>
-        <p:spPr/>
-        <p:txBody>
-          <a:bodyPr/>
-          <a:lstStyle/>
-          <a:p>
-            <a:pPr marL="0" indent="0">
-              <a:buNone/>
-            </a:pPr>
-            <a:r>
-              <a:rPr lang="da-DK" dirty="0"/>
-              <a:t>Perform time </a:t>
-            </a:r>
-            <a:r>
-              <a:rPr lang="da-DK" dirty="0" err="1"/>
-              <a:t>consuming</a:t>
-            </a:r>
-            <a:r>
-              <a:rPr lang="da-DK" dirty="0"/>
-              <a:t> </a:t>
-            </a:r>
-            <a:r>
-              <a:rPr lang="da-DK" dirty="0" err="1"/>
-              <a:t>work</a:t>
-            </a:r>
-            <a:r>
-              <a:rPr lang="da-DK" dirty="0"/>
-              <a:t> and still have a </a:t>
-            </a:r>
-            <a:r>
-              <a:rPr lang="da-DK" dirty="0" err="1"/>
-              <a:t>responsive</a:t>
-            </a:r>
-            <a:r>
-              <a:rPr lang="da-DK" dirty="0"/>
-              <a:t> UI.</a:t>
-            </a:r>
-          </a:p>
-          <a:p>
-            <a:pPr marL="0" indent="0">
-              <a:buNone/>
-            </a:pPr>
-            <a:endParaRPr lang="da-DK" dirty="0"/>
-          </a:p>
-          <a:p>
-            <a:pPr marL="0" indent="0">
-              <a:buNone/>
-            </a:pPr>
-            <a:r>
-              <a:rPr lang="da-DK" dirty="0" err="1"/>
-              <a:t>Inform</a:t>
-            </a:r>
-            <a:r>
-              <a:rPr lang="da-DK" dirty="0"/>
-              <a:t> the user </a:t>
-            </a:r>
-            <a:r>
-              <a:rPr lang="da-DK" dirty="0" err="1"/>
-              <a:t>about</a:t>
-            </a:r>
-            <a:r>
-              <a:rPr lang="da-DK" dirty="0"/>
-              <a:t> the </a:t>
-            </a:r>
-            <a:r>
-              <a:rPr lang="da-DK" dirty="0" err="1"/>
-              <a:t>state</a:t>
-            </a:r>
-            <a:r>
-              <a:rPr lang="da-DK" dirty="0"/>
-              <a:t> of the </a:t>
-            </a:r>
-            <a:r>
-              <a:rPr lang="da-DK" dirty="0" err="1"/>
-              <a:t>work</a:t>
-            </a:r>
-            <a:r>
-              <a:rPr lang="da-DK" dirty="0"/>
-              <a:t> in </a:t>
-            </a:r>
-            <a:r>
-              <a:rPr lang="da-DK" dirty="0" err="1"/>
-              <a:t>progress</a:t>
-            </a:r>
-            <a:r>
-              <a:rPr lang="da-DK" dirty="0"/>
-              <a:t>.</a:t>
-            </a:r>
-          </a:p>
-          <a:p>
-            <a:pPr marL="0" indent="0">
-              <a:buNone/>
-            </a:pPr>
-            <a:endParaRPr lang="da-DK" dirty="0"/>
-          </a:p>
-          <a:p>
-            <a:pPr marL="0" indent="0">
-              <a:buNone/>
-            </a:pPr>
-            <a:r>
-              <a:rPr lang="da-DK" dirty="0" err="1"/>
-              <a:t>React</a:t>
-            </a:r>
-            <a:r>
-              <a:rPr lang="da-DK" dirty="0"/>
-              <a:t> </a:t>
-            </a:r>
-            <a:r>
-              <a:rPr lang="da-DK" dirty="0" err="1"/>
-              <a:t>when</a:t>
-            </a:r>
-            <a:r>
-              <a:rPr lang="da-DK" dirty="0"/>
-              <a:t> </a:t>
-            </a:r>
-            <a:r>
-              <a:rPr lang="da-DK" dirty="0" err="1"/>
-              <a:t>work</a:t>
-            </a:r>
-            <a:r>
-              <a:rPr lang="da-DK" dirty="0"/>
-              <a:t> is </a:t>
-            </a:r>
-            <a:r>
-              <a:rPr lang="da-DK" dirty="0" err="1"/>
-              <a:t>complete</a:t>
-            </a:r>
-            <a:endParaRPr lang="da-DK" dirty="0"/>
-          </a:p>
-          <a:p>
-            <a:pPr lvl="1">
-              <a:buFontTx/>
-              <a:buChar char="-"/>
-            </a:pPr>
-            <a:r>
-              <a:rPr lang="da-DK" dirty="0" err="1"/>
-              <a:t>Inform</a:t>
-            </a:r>
-            <a:r>
-              <a:rPr lang="da-DK" dirty="0"/>
-              <a:t> the user.</a:t>
-            </a:r>
-          </a:p>
-          <a:p>
-            <a:pPr lvl="1">
-              <a:buFontTx/>
-              <a:buChar char="-"/>
-            </a:pPr>
-            <a:r>
-              <a:rPr lang="da-DK" dirty="0"/>
-              <a:t>Do </a:t>
-            </a:r>
-            <a:r>
-              <a:rPr lang="da-DK" dirty="0" err="1"/>
-              <a:t>something</a:t>
-            </a:r>
-            <a:r>
-              <a:rPr lang="da-DK" dirty="0"/>
-              <a:t> </a:t>
-            </a:r>
-            <a:r>
-              <a:rPr lang="da-DK" dirty="0" err="1"/>
-              <a:t>based</a:t>
-            </a:r>
-            <a:r>
-              <a:rPr lang="da-DK" dirty="0"/>
-              <a:t> on the </a:t>
-            </a:r>
-            <a:r>
-              <a:rPr lang="da-DK" dirty="0" err="1"/>
-              <a:t>result</a:t>
-            </a:r>
-            <a:r>
-              <a:rPr lang="da-DK" dirty="0"/>
-              <a:t>.</a:t>
-            </a:r>
-          </a:p>
-          <a:p>
-            <a:pPr lvl="1">
-              <a:buFontTx/>
-              <a:buChar char="-"/>
-            </a:pPr>
-            <a:endParaRPr lang="da-DK" dirty="0"/>
-          </a:p>
-          <a:p>
-            <a:pPr marL="0" indent="0">
-              <a:buNone/>
-            </a:pPr>
-            <a:r>
-              <a:rPr lang="da-DK" dirty="0"/>
-              <a:t>Be </a:t>
-            </a:r>
-            <a:r>
-              <a:rPr lang="da-DK" dirty="0" err="1"/>
-              <a:t>able</a:t>
-            </a:r>
-            <a:r>
-              <a:rPr lang="da-DK" dirty="0"/>
-              <a:t> to </a:t>
-            </a:r>
-            <a:r>
-              <a:rPr lang="da-DK" dirty="0" err="1"/>
-              <a:t>cancel</a:t>
-            </a:r>
-            <a:r>
-              <a:rPr lang="da-DK" dirty="0"/>
-              <a:t> the </a:t>
-            </a:r>
-            <a:r>
-              <a:rPr lang="da-DK" dirty="0" err="1"/>
-              <a:t>work</a:t>
-            </a:r>
-            <a:r>
-              <a:rPr lang="da-DK" dirty="0"/>
-              <a:t> </a:t>
-            </a:r>
-            <a:r>
-              <a:rPr lang="da-DK" dirty="0" err="1"/>
-              <a:t>being</a:t>
-            </a:r>
-            <a:r>
-              <a:rPr lang="da-DK" dirty="0"/>
-              <a:t> </a:t>
-            </a:r>
-            <a:r>
-              <a:rPr lang="da-DK" dirty="0" err="1"/>
-              <a:t>performed</a:t>
-            </a:r>
-            <a:r>
-              <a:rPr lang="da-DK" dirty="0"/>
-              <a:t>.</a:t>
-            </a:r>
-          </a:p>
-        </p:txBody>
-      </p:sp>
-      <p:pic>
-        <p:nvPicPr>
-          <p:cNvPr id="4" name="Content Placeholder 3"/>
-          <p:cNvPicPr>
-            <a:picLocks noChangeAspect="1"/>
-          </p:cNvPicPr>
-          <p:nvPr/>
-        </p:nvPicPr>
-        <p:blipFill>
-          <a:blip r:embed="rId3">
-            <a:extLst>
-              <a:ext uri="{28A0092B-C50C-407E-A947-70E740481C1C}">
-                <a14:useLocalDpi xmlns:a14="http://schemas.microsoft.com/office/drawing/2010/main" val="0"/>
-              </a:ext>
-            </a:extLst>
-          </a:blip>
-          <a:stretch>
-            <a:fillRect/>
-          </a:stretch>
-        </p:blipFill>
-        <p:spPr>
-          <a:xfrm>
-            <a:off x="8314515" y="4286929"/>
-            <a:ext cx="3714750" cy="2324100"/>
-          </a:xfrm>
-          <a:prstGeom prst="rect">
-            <a:avLst/>
-          </a:prstGeom>
-        </p:spPr>
-      </p:pic>
-    </p:spTree>
-    <p:extLst>
-      <p:ext uri="{BB962C8B-B14F-4D97-AF65-F5344CB8AC3E}">
-        <p14:creationId xmlns:p14="http://schemas.microsoft.com/office/powerpoint/2010/main" val="828014206"/>
-      </p:ext>
-    </p:extLst>
-  </p:cSld>
-  <p:clrMapOvr>
-    <a:masterClrMapping/>
-  </p:clrMapOvr>
-</p:sld>
-</file>
-
-<file path=ppt/slides/slide43.xml><?xml version="1.0" encoding="utf-8"?>
 <p:sld xmlns:a="http://schemas.openxmlformats.org/drawingml/2006/main" xmlns:r="http://schemas.openxmlformats.org/officeDocument/2006/relationships" xmlns:p="http://schemas.openxmlformats.org/presentationml/2006/main">
   <p:cSld>
     <p:spTree>
@@ -32611,6 +32170,431 @@
     <p:extLst>
       <p:ext uri="{BB962C8B-B14F-4D97-AF65-F5344CB8AC3E}">
         <p14:creationId xmlns:p14="http://schemas.microsoft.com/office/powerpoint/2010/main" val="3569189014"/>
+      </p:ext>
+    </p:extLst>
+  </p:cSld>
+  <p:clrMapOvr>
+    <a:masterClrMapping/>
+  </p:clrMapOvr>
+</p:sld>
+</file>
+
+<file path=ppt/slides/slide42.xml><?xml version="1.0" encoding="utf-8"?>
+<p:sld xmlns:a="http://schemas.openxmlformats.org/drawingml/2006/main" xmlns:r="http://schemas.openxmlformats.org/officeDocument/2006/relationships" xmlns:p="http://schemas.openxmlformats.org/presentationml/2006/main">
+  <p:cSld>
+    <p:spTree>
+      <p:nvGrpSpPr>
+        <p:cNvPr id="1" name=""/>
+        <p:cNvGrpSpPr/>
+        <p:nvPr/>
+      </p:nvGrpSpPr>
+      <p:grpSpPr>
+        <a:xfrm>
+          <a:off x="0" y="0"/>
+          <a:ext cx="0" cy="0"/>
+          <a:chOff x="0" y="0"/>
+          <a:chExt cx="0" cy="0"/>
+        </a:xfrm>
+      </p:grpSpPr>
+      <p:sp>
+        <p:nvSpPr>
+          <p:cNvPr id="2" name="Title 1"/>
+          <p:cNvSpPr>
+            <a:spLocks noGrp="1"/>
+          </p:cNvSpPr>
+          <p:nvPr>
+            <p:ph type="title"/>
+          </p:nvPr>
+        </p:nvSpPr>
+        <p:spPr/>
+        <p:txBody>
+          <a:bodyPr/>
+          <a:lstStyle/>
+          <a:p>
+            <a:r>
+              <a:rPr lang="da-DK" dirty="0"/>
+              <a:t>Extra </a:t>
+            </a:r>
+            <a:r>
+              <a:rPr lang="da-DK" dirty="0" err="1"/>
+              <a:t>stuff</a:t>
+            </a:r>
+            <a:endParaRPr lang="da-DK" dirty="0"/>
+          </a:p>
+        </p:txBody>
+      </p:sp>
+      <p:pic>
+        <p:nvPicPr>
+          <p:cNvPr id="4" name="Content Placeholder 3"/>
+          <p:cNvPicPr>
+            <a:picLocks noGrp="1" noChangeAspect="1"/>
+          </p:cNvPicPr>
+          <p:nvPr>
+            <p:ph idx="1"/>
+          </p:nvPr>
+        </p:nvPicPr>
+        <p:blipFill>
+          <a:blip r:embed="rId2">
+            <a:extLst>
+              <a:ext uri="{28A0092B-C50C-407E-A947-70E740481C1C}">
+                <a14:useLocalDpi xmlns:a14="http://schemas.microsoft.com/office/drawing/2010/main" val="0"/>
+              </a:ext>
+            </a:extLst>
+          </a:blip>
+          <a:stretch>
+            <a:fillRect/>
+          </a:stretch>
+        </p:blipFill>
+        <p:spPr>
+          <a:xfrm>
+            <a:off x="1033764" y="2022959"/>
+            <a:ext cx="10124472" cy="3442320"/>
+          </a:xfrm>
+        </p:spPr>
+      </p:pic>
+    </p:spTree>
+    <p:extLst>
+      <p:ext uri="{BB962C8B-B14F-4D97-AF65-F5344CB8AC3E}">
+        <p14:creationId xmlns:p14="http://schemas.microsoft.com/office/powerpoint/2010/main" val="293524918"/>
+      </p:ext>
+    </p:extLst>
+  </p:cSld>
+  <p:clrMapOvr>
+    <a:masterClrMapping/>
+  </p:clrMapOvr>
+</p:sld>
+</file>
+
+<file path=ppt/slides/slide43.xml><?xml version="1.0" encoding="utf-8"?>
+<p:sld xmlns:a="http://schemas.openxmlformats.org/drawingml/2006/main" xmlns:r="http://schemas.openxmlformats.org/officeDocument/2006/relationships" xmlns:p="http://schemas.openxmlformats.org/presentationml/2006/main">
+  <p:cSld>
+    <p:spTree>
+      <p:nvGrpSpPr>
+        <p:cNvPr id="1" name=""/>
+        <p:cNvGrpSpPr/>
+        <p:nvPr/>
+      </p:nvGrpSpPr>
+      <p:grpSpPr>
+        <a:xfrm>
+          <a:off x="0" y="0"/>
+          <a:ext cx="0" cy="0"/>
+          <a:chOff x="0" y="0"/>
+          <a:chExt cx="0" cy="0"/>
+        </a:xfrm>
+      </p:grpSpPr>
+      <p:sp>
+        <p:nvSpPr>
+          <p:cNvPr id="2" name="Title 1"/>
+          <p:cNvSpPr>
+            <a:spLocks noGrp="1"/>
+          </p:cNvSpPr>
+          <p:nvPr>
+            <p:ph type="title"/>
+          </p:nvPr>
+        </p:nvSpPr>
+        <p:spPr/>
+        <p:txBody>
+          <a:bodyPr/>
+          <a:lstStyle/>
+          <a:p>
+            <a:r>
+              <a:rPr lang="da-DK" dirty="0"/>
+              <a:t>Not </a:t>
+            </a:r>
+            <a:r>
+              <a:rPr lang="da-DK" dirty="0" err="1"/>
+              <a:t>solved</a:t>
+            </a:r>
+            <a:r>
+              <a:rPr lang="da-DK" dirty="0"/>
+              <a:t> </a:t>
+            </a:r>
+            <a:r>
+              <a:rPr lang="da-DK" dirty="0" err="1"/>
+              <a:t>here</a:t>
+            </a:r>
+            <a:endParaRPr lang="da-DK" dirty="0"/>
+          </a:p>
+        </p:txBody>
+      </p:sp>
+      <p:sp>
+        <p:nvSpPr>
+          <p:cNvPr id="3" name="Content Placeholder 2"/>
+          <p:cNvSpPr>
+            <a:spLocks noGrp="1"/>
+          </p:cNvSpPr>
+          <p:nvPr>
+            <p:ph idx="1"/>
+          </p:nvPr>
+        </p:nvSpPr>
+        <p:spPr/>
+        <p:txBody>
+          <a:bodyPr/>
+          <a:lstStyle/>
+          <a:p>
+            <a:pPr marL="0" indent="0">
+              <a:buNone/>
+            </a:pPr>
+            <a:r>
+              <a:rPr lang="da-DK" dirty="0"/>
+              <a:t>Perform time </a:t>
+            </a:r>
+            <a:r>
+              <a:rPr lang="da-DK" dirty="0" err="1"/>
+              <a:t>consuming</a:t>
+            </a:r>
+            <a:r>
+              <a:rPr lang="da-DK" dirty="0"/>
+              <a:t> </a:t>
+            </a:r>
+            <a:r>
+              <a:rPr lang="da-DK" dirty="0" err="1"/>
+              <a:t>work</a:t>
+            </a:r>
+            <a:r>
+              <a:rPr lang="da-DK" dirty="0"/>
+              <a:t> and still have a </a:t>
+            </a:r>
+            <a:r>
+              <a:rPr lang="da-DK" dirty="0" err="1"/>
+              <a:t>responsive</a:t>
+            </a:r>
+            <a:r>
+              <a:rPr lang="da-DK" dirty="0"/>
+              <a:t> UI.</a:t>
+            </a:r>
+          </a:p>
+          <a:p>
+            <a:pPr marL="0" indent="0">
+              <a:buNone/>
+            </a:pPr>
+            <a:endParaRPr lang="da-DK" dirty="0"/>
+          </a:p>
+          <a:p>
+            <a:pPr marL="0" indent="0">
+              <a:buNone/>
+            </a:pPr>
+            <a:r>
+              <a:rPr lang="da-DK" dirty="0" err="1"/>
+              <a:t>Inform</a:t>
+            </a:r>
+            <a:r>
+              <a:rPr lang="da-DK" dirty="0"/>
+              <a:t> the user </a:t>
+            </a:r>
+            <a:r>
+              <a:rPr lang="da-DK" dirty="0" err="1"/>
+              <a:t>about</a:t>
+            </a:r>
+            <a:r>
+              <a:rPr lang="da-DK" dirty="0"/>
+              <a:t> the </a:t>
+            </a:r>
+            <a:r>
+              <a:rPr lang="da-DK" dirty="0" err="1"/>
+              <a:t>state</a:t>
+            </a:r>
+            <a:r>
+              <a:rPr lang="da-DK" dirty="0"/>
+              <a:t> of the </a:t>
+            </a:r>
+            <a:r>
+              <a:rPr lang="da-DK" dirty="0" err="1"/>
+              <a:t>work</a:t>
+            </a:r>
+            <a:r>
+              <a:rPr lang="da-DK" dirty="0"/>
+              <a:t> in </a:t>
+            </a:r>
+            <a:r>
+              <a:rPr lang="da-DK" dirty="0" err="1"/>
+              <a:t>progress</a:t>
+            </a:r>
+            <a:r>
+              <a:rPr lang="da-DK" dirty="0"/>
+              <a:t>.</a:t>
+            </a:r>
+          </a:p>
+          <a:p>
+            <a:pPr marL="0" indent="0">
+              <a:buNone/>
+            </a:pPr>
+            <a:endParaRPr lang="da-DK" dirty="0"/>
+          </a:p>
+          <a:p>
+            <a:pPr marL="0" indent="0">
+              <a:buNone/>
+            </a:pPr>
+            <a:r>
+              <a:rPr lang="da-DK" dirty="0" err="1"/>
+              <a:t>React</a:t>
+            </a:r>
+            <a:r>
+              <a:rPr lang="da-DK" dirty="0"/>
+              <a:t> </a:t>
+            </a:r>
+            <a:r>
+              <a:rPr lang="da-DK" dirty="0" err="1"/>
+              <a:t>when</a:t>
+            </a:r>
+            <a:r>
+              <a:rPr lang="da-DK" dirty="0"/>
+              <a:t> </a:t>
+            </a:r>
+            <a:r>
+              <a:rPr lang="da-DK" dirty="0" err="1"/>
+              <a:t>work</a:t>
+            </a:r>
+            <a:r>
+              <a:rPr lang="da-DK" dirty="0"/>
+              <a:t> is </a:t>
+            </a:r>
+            <a:r>
+              <a:rPr lang="da-DK" dirty="0" err="1"/>
+              <a:t>complete</a:t>
+            </a:r>
+            <a:endParaRPr lang="da-DK" dirty="0"/>
+          </a:p>
+          <a:p>
+            <a:pPr lvl="1">
+              <a:buFontTx/>
+              <a:buChar char="-"/>
+            </a:pPr>
+            <a:r>
+              <a:rPr lang="da-DK" dirty="0" err="1"/>
+              <a:t>Inform</a:t>
+            </a:r>
+            <a:r>
+              <a:rPr lang="da-DK" dirty="0"/>
+              <a:t> the user.</a:t>
+            </a:r>
+          </a:p>
+          <a:p>
+            <a:pPr lvl="1">
+              <a:buFontTx/>
+              <a:buChar char="-"/>
+            </a:pPr>
+            <a:r>
+              <a:rPr lang="da-DK" dirty="0"/>
+              <a:t>Do </a:t>
+            </a:r>
+            <a:r>
+              <a:rPr lang="da-DK" dirty="0" err="1"/>
+              <a:t>something</a:t>
+            </a:r>
+            <a:r>
+              <a:rPr lang="da-DK" dirty="0"/>
+              <a:t> </a:t>
+            </a:r>
+            <a:r>
+              <a:rPr lang="da-DK" dirty="0" err="1"/>
+              <a:t>based</a:t>
+            </a:r>
+            <a:r>
+              <a:rPr lang="da-DK" dirty="0"/>
+              <a:t> on the </a:t>
+            </a:r>
+            <a:r>
+              <a:rPr lang="da-DK" dirty="0" err="1"/>
+              <a:t>result</a:t>
+            </a:r>
+            <a:r>
+              <a:rPr lang="da-DK" dirty="0"/>
+              <a:t>.</a:t>
+            </a:r>
+          </a:p>
+          <a:p>
+            <a:pPr lvl="1">
+              <a:buFontTx/>
+              <a:buChar char="-"/>
+            </a:pPr>
+            <a:endParaRPr lang="da-DK" dirty="0"/>
+          </a:p>
+          <a:p>
+            <a:pPr marL="0" indent="0">
+              <a:buNone/>
+            </a:pPr>
+            <a:r>
+              <a:rPr lang="da-DK" dirty="0"/>
+              <a:t>Be </a:t>
+            </a:r>
+            <a:r>
+              <a:rPr lang="da-DK" dirty="0" err="1"/>
+              <a:t>able</a:t>
+            </a:r>
+            <a:r>
+              <a:rPr lang="da-DK" dirty="0"/>
+              <a:t> to </a:t>
+            </a:r>
+            <a:r>
+              <a:rPr lang="da-DK" dirty="0" err="1"/>
+              <a:t>cancel</a:t>
+            </a:r>
+            <a:r>
+              <a:rPr lang="da-DK" dirty="0"/>
+              <a:t> the </a:t>
+            </a:r>
+            <a:r>
+              <a:rPr lang="da-DK" dirty="0" err="1"/>
+              <a:t>work</a:t>
+            </a:r>
+            <a:r>
+              <a:rPr lang="da-DK" dirty="0"/>
+              <a:t> </a:t>
+            </a:r>
+            <a:r>
+              <a:rPr lang="da-DK" dirty="0" err="1"/>
+              <a:t>being</a:t>
+            </a:r>
+            <a:r>
+              <a:rPr lang="da-DK" dirty="0"/>
+              <a:t> </a:t>
+            </a:r>
+            <a:r>
+              <a:rPr lang="da-DK" dirty="0" err="1"/>
+              <a:t>performed</a:t>
+            </a:r>
+            <a:r>
+              <a:rPr lang="da-DK" dirty="0"/>
+              <a:t>.</a:t>
+            </a:r>
+          </a:p>
+        </p:txBody>
+      </p:sp>
+      <p:pic>
+        <p:nvPicPr>
+          <p:cNvPr id="4" name="Content Placeholder 3"/>
+          <p:cNvPicPr>
+            <a:picLocks noChangeAspect="1"/>
+          </p:cNvPicPr>
+          <p:nvPr/>
+        </p:nvPicPr>
+        <p:blipFill>
+          <a:blip r:embed="rId3">
+            <a:extLst>
+              <a:ext uri="{28A0092B-C50C-407E-A947-70E740481C1C}">
+                <a14:useLocalDpi xmlns:a14="http://schemas.microsoft.com/office/drawing/2010/main" val="0"/>
+              </a:ext>
+            </a:extLst>
+          </a:blip>
+          <a:stretch>
+            <a:fillRect/>
+          </a:stretch>
+        </p:blipFill>
+        <p:spPr>
+          <a:xfrm>
+            <a:off x="8314515" y="4286929"/>
+            <a:ext cx="3714750" cy="2324100"/>
+          </a:xfrm>
+          <a:prstGeom prst="rect">
+            <a:avLst/>
+          </a:prstGeom>
+        </p:spPr>
+      </p:pic>
+    </p:spTree>
+    <p:extLst>
+      <p:ext uri="{BB962C8B-B14F-4D97-AF65-F5344CB8AC3E}">
+        <p14:creationId xmlns:p14="http://schemas.microsoft.com/office/powerpoint/2010/main" val="828014206"/>
       </p:ext>
     </p:extLst>
   </p:cSld>

</xml_diff>